<commit_message>
tcc: revisao completa, enxugado, literatura academica e objetivos retomados
</commit_message>
<xml_diff>
--- a/apresentacao/apresentacao-tcc2.pptx
+++ b/apresentacao/apresentacao-tcc2.pptx
@@ -125,7 +125,7 @@
   <p:extLst>
     <p:ext uri="{521415D9-36F7-43E2-AB2F-B90AF26B5E84}">
       <p14:sectionLst xmlns:p14="http://schemas.microsoft.com/office/powerpoint/2010/main">
-        <p14:section name="Abertura" id="{5a9d5ab7-b30e-339d-d782-937527870388}">
+        <p14:section name="Abertura" id="{c6e86656-be14-b955-d618-24926ade37dc}">
           <p14:sldIdLst>
             <p14:sldId id="256"/>
             <p14:sldId id="257"/>
@@ -133,20 +133,20 @@
             <p14:sldId id="259"/>
           </p14:sldIdLst>
         </p14:section>
-        <p14:section name="Plataforma" id="{61206299-a427-7e56-0b51-600e52a6bafc}">
+        <p14:section name="Plataforma" id="{6a24574b-a084-2af7-da34-629f55684a5e}">
           <p14:sldIdLst>
             <p14:sldId id="260"/>
             <p14:sldId id="261"/>
             <p14:sldId id="262"/>
           </p14:sldIdLst>
         </p14:section>
-        <p14:section name="Qualidade do dado" id="{26ce62b4-4e45-e995-ef76-515a5c660e26}">
+        <p14:section name="Qualidade do dado" id="{af05ffec-a28b-e721-10b6-f5fc19179f11}">
           <p14:sldIdLst>
             <p14:sldId id="263"/>
             <p14:sldId id="264"/>
           </p14:sldIdLst>
         </p14:section>
-        <p14:section name="Resultados" id="{5f1c7b34-ce04-5f18-6d27-77883b0c71bf}">
+        <p14:section name="Resultados" id="{9fb5d6fd-0f6c-3d49-c4dc-79627e7b6d94}">
           <p14:sldIdLst>
             <p14:sldId id="265"/>
             <p14:sldId id="266"/>
@@ -156,7 +156,7 @@
             <p14:sldId id="270"/>
           </p14:sldIdLst>
         </p14:section>
-        <p14:section name="Entrega" id="{a6b07502-ac7d-8c0c-1677-b4c672df976a}">
+        <p14:section name="Entrega" id="{89ead869-68a9-dfc8-bab4-783de9243984}">
           <p14:sldIdLst>
             <p14:sldId id="271"/>
             <p14:sldId id="272"/>
@@ -2242,7 +2242,7 @@
                 </a:solidFill>
                 <a:latin typeface="+mn-lt"/>
               </a:rPr>
-              <a:t>Nowcast de 2025 (ano retido): erro por estimador</a:t>
+              <a:t>Nowcast: erro médio em 12 anos retidos (2014–2025)</a:t>
             </a:r>
           </a:p>
         </c:rich>
@@ -2266,7 +2266,7 @@
               <c:strCache>
                 <c:ptCount val="1"/>
                 <c:pt idx="0">
-                  <c:v>Erro absoluto (%)</c:v>
+                  <c:v>Erro médio (%)</c:v>
                 </c:pt>
               </c:strCache>
             </c:strRef>
@@ -2309,13 +2309,13 @@
                 <c:ptCount val="4"/>
                 <c:lvl>
                   <c:pt idx="0">
+                    <c:v>Identidade</c:v>
+                  </c:pt>
+                  <c:pt idx="1">
                     <c:v>Razão mediana</c:v>
                   </c:pt>
-                  <c:pt idx="1">
+                  <c:pt idx="2">
                     <c:v>Regressão OLS</c:v>
-                  </c:pt>
-                  <c:pt idx="2">
-                    <c:v>Identidade</c:v>
                   </c:pt>
                   <c:pt idx="3">
                     <c:v>Ingênuo</c:v>
@@ -2331,16 +2331,16 @@
                 <c:formatCode>General</c:formatCode>
                 <c:ptCount val="4"/>
                 <c:pt idx="0">
-                  <c:v>0.78</c:v>
+                  <c:v>2.12</c:v>
                 </c:pt>
                 <c:pt idx="1">
-                  <c:v>0.86</c:v>
+                  <c:v>2.18</c:v>
                 </c:pt>
                 <c:pt idx="2">
-                  <c:v>1.43</c:v>
+                  <c:v>2.49</c:v>
                 </c:pt>
                 <c:pt idx="3">
-                  <c:v>3.67</c:v>
+                  <c:v>5.09</c:v>
                 </c:pt>
               </c:numCache>
             </c:numRef>
@@ -2419,7 +2419,7 @@
         <c:axId val="2094734552"/>
         <c:scaling>
           <c:orientation val="minMax"/>
-          <c:max val="4.5"/>
+          <c:max val="6.2"/>
           <c:min val="0"/>
         </c:scaling>
         <c:delete val="1"/>
@@ -3412,7 +3412,7 @@
           <a:p>
             <a:r>
               <a:rPr lang="en-US" dirty="0"/>
-              <a:t>Na previsão, o SARIMA escolhido por validação de origem móvel erra 31% menos que repetir o mesmo mês do ano anterior. Mas o intervalo cruza o zero ao fim do primeiro ano, então projetar até 2030, como a proposta previa, seria um número sem conteúdo — reporto 18 meses com intervalo. O resultado forte é o nowcast: estimar o estoque do ano corrente, que a RAIS só publica um ano depois, a partir do fluxo do CAGED. Ajustado sem 2025 e testado em 2025, o melhor estimador errou 0,78%. Estimar o presente rende mais do que prever o futuro.</a:t>
+              <a:t>Na previsão, o SARIMA escolhido por validação de origem móvel erra 31% menos que repetir o mesmo mês do ano anterior. O Prophet, que estava na proposta, entrou na mesma validação: o melhor ficou em 16%, e com a tendência padrão ficou pior que o ingênuo — a série é completa e de sazonalidade estável, terreno do SARIMA. Mas o intervalo cruza o zero ao fim do primeiro ano, então projetar até 2030, como a proposta previa, seria um número sem conteúdo — reporto 18 meses com intervalo. O resultado forte é o nowcast: estimar o estoque do ano corrente, que a RAIS só publica um ano depois, a partir do fluxo do CAGED. Testei cada ano de 2014 a 2025 estimando só com os anos anteriores: o melhor estimador erra em média 2,1%, contra 5,1% do ingênuo, e em dez dos doze anos até 2,2%. Os anos ruins, 2018 e 2022, são saltos do estoque que o fluxo do CAGED não mostra. Estimar o presente rende mais do que prever o futuro.</a:t>
             </a:r>
             <a:endParaRPr lang="en-US" dirty="0"/>
           </a:p>
@@ -3676,7 +3676,7 @@
           <a:p>
             <a:r>
               <a:rPr lang="en-US" dirty="0"/>
-              <a:t>As limitações estão declaradas. A RAIS e o CAGED só veem o mercado formal, e em TI a contratação como PJ é comum. A localização é a do estabelecimento. A decomposição não mede discriminação. A validação externa cobre só a lente de ocupação, e o Prophet, previsto na proposta, não foi avaliado. Como próximos passos: medir retenção por gênero cruzando as duas bases, a decomposição regional, e reaproveitar o pipeline para outros recortes — basta trocar a lista de códigos.</a:t>
+              <a:t>As limitações estão declaradas. A RAIS e o CAGED só veem o mercado formal, e em TI a contratação como PJ é comum. A localização é a do estabelecimento. A decomposição não mede discriminação. A validação externa cobre só a lente de ocupação — estendê-la à lente de setor com o cadastro de empresas do IBGE fica como trabalho futuro —, e o nowcast erra mais nos anos de salto do estoque. Como próximos passos: medir retenção por gênero cruzando as duas bases, a decomposição regional, e reaproveitar o pipeline para outros recortes — basta trocar a lista de códigos.</a:t>
             </a:r>
             <a:endParaRPr lang="en-US" dirty="0"/>
           </a:p>
@@ -7372,14 +7372,14 @@
               <a:buNone/>
             </a:pPr>
             <a:r>
-              <a:rPr lang="en-US" sz="4400" b="1" dirty="0">
+              <a:rPr lang="en-US" sz="3600" b="1" dirty="0">
                 <a:solidFill>
                   <a:schemeClr val="tx1"/>
                 </a:solidFill>
               </a:rPr>
-              <a:t>31%</a:t>
-            </a:r>
-            <a:endParaRPr lang="en-US" sz="4400" dirty="0"/>
+              <a:t>31% × 16%</a:t>
+            </a:r>
+            <a:endParaRPr lang="en-US" sz="3600" dirty="0"/>
           </a:p>
         </p:txBody>
       </p:sp>
@@ -7413,7 +7413,7 @@
                   <a:schemeClr val="tx2"/>
                 </a:solidFill>
               </a:rPr>
-              <a:t>menos erro que o ingênuo sazonal (SARIMA, validação de origem móvel em 5 dobras)</a:t>
+              <a:t>menos erro que o ingênuo sazonal: melhor SARIMA × melhor Prophet, nas mesmas 5 dobras</a:t>
             </a:r>
             <a:endParaRPr lang="en-US" sz="1400" dirty="0"/>
           </a:p>
@@ -7507,7 +7507,7 @@
                   <a:schemeClr val="tx1"/>
                 </a:solidFill>
               </a:rPr>
-              <a:t>O estoque do ano corrente sai do último estoque e do fluxo já publicado pelo CAGED — um ano antes da RAIS.</a:t>
+              <a:t>Cada ano estimado só com os anteriores. Em 10 dos 12 anos, erro de até 2,2%; os piores são 2018 e 2022, saltos que o fluxo não antecipa.</a:t>
             </a:r>
             <a:endParaRPr lang="en-US" sz="1500" dirty="0"/>
           </a:p>
@@ -8793,7 +8793,7 @@
                   <a:schemeClr val="tx1"/>
                 </a:solidFill>
               </a:rPr>
-              <a:t>Futuro incerto; presente estimado com erro de 0,78%</a:t>
+              <a:t>Futuro incerto; presente estimado com erro médio de 2,1%</a:t>
             </a:r>
             <a:endParaRPr lang="en-US" sz="1600" dirty="0"/>
           </a:p>
@@ -9177,7 +9177,7 @@
                   <a:schemeClr val="tx1"/>
                 </a:solidFill>
               </a:rPr>
-              <a:t>Validação externa só na lente de ocupação; Prophet não avaliado</a:t>
+              <a:t>Validação externa só na lente de ocupação; nowcast erra mais em anos de salto</a:t>
             </a:r>
             <a:endParaRPr lang="en-US" sz="1500" dirty="0"/>
           </a:p>

</xml_diff>

<commit_message>
correcao da duplicata de 2007 no CAGED, reprodutibilidade do CAGED e limpeza do texto
</commit_message>
<xml_diff>
--- a/apresentacao/apresentacao-tcc2.pptx
+++ b/apresentacao/apresentacao-tcc2.pptx
@@ -125,7 +125,7 @@
   <p:extLst>
     <p:ext uri="{521415D9-36F7-43E2-AB2F-B90AF26B5E84}">
       <p14:sectionLst xmlns:p14="http://schemas.microsoft.com/office/powerpoint/2010/main">
-        <p14:section name="Abertura" id="{c6e86656-be14-b955-d618-24926ade37dc}">
+        <p14:section name="Abertura" id="{f648f3eb-65d4-66eb-081d-f1713f95cfb3}">
           <p14:sldIdLst>
             <p14:sldId id="256"/>
             <p14:sldId id="257"/>
@@ -133,20 +133,20 @@
             <p14:sldId id="259"/>
           </p14:sldIdLst>
         </p14:section>
-        <p14:section name="Plataforma" id="{6a24574b-a084-2af7-da34-629f55684a5e}">
+        <p14:section name="Plataforma" id="{1e8f2bde-f0cd-0341-c0a5-d106bba380c0}">
           <p14:sldIdLst>
             <p14:sldId id="260"/>
             <p14:sldId id="261"/>
             <p14:sldId id="262"/>
           </p14:sldIdLst>
         </p14:section>
-        <p14:section name="Qualidade do dado" id="{af05ffec-a28b-e721-10b6-f5fc19179f11}">
+        <p14:section name="Qualidade do dado" id="{ffa71e92-cd58-196a-87a3-0f1384723458}">
           <p14:sldIdLst>
             <p14:sldId id="263"/>
             <p14:sldId id="264"/>
           </p14:sldIdLst>
         </p14:section>
-        <p14:section name="Resultados" id="{9fb5d6fd-0f6c-3d49-c4dc-79627e7b6d94}">
+        <p14:section name="Resultados" id="{4afde783-0b7d-ee5a-a22d-f80d5f6bd7cd}">
           <p14:sldIdLst>
             <p14:sldId id="265"/>
             <p14:sldId id="266"/>
@@ -156,7 +156,7 @@
             <p14:sldId id="270"/>
           </p14:sldIdLst>
         </p14:section>
-        <p14:section name="Entrega" id="{89ead869-68a9-dfc8-bab4-783de9243984}">
+        <p14:section name="Entrega" id="{97aed8af-72c2-a1ff-f462-1f0a388eab53}">
           <p14:sldIdLst>
             <p14:sldId id="271"/>
             <p14:sldId id="272"/>
@@ -2972,7 +2972,7 @@
           <a:p>
             <a:r>
               <a:rPr lang="en-US" dirty="0"/>
-              <a:t>Primeira resposta: o estoque passou de 560 mil vínculos em 2007 para 1,36 milhão em 2025, crescimento de 143%. O crescimento não é uniforme: o salto está em 2021 e 2022, a aceleração digital da pandemia, e depois desacelera. O CAGED confirma, com quase 700 mil vagas líquidas no período. A diferença entre o saldo do CAGED e a variação da RAIS não é erro — as bases têm cobertura e prazos diferentes — e é justamente o que o nowcast da pergunta 5 modela.</a:t>
+              <a:t>Primeira resposta: o estoque passou de 560 mil vínculos em 2007 para 1,36 milhão em 2025, crescimento de 143%. O crescimento não é uniforme: o salto está em 2021 e 2022, a aceleração digital da pandemia, e depois desacelera. O CAGED confirma, com cerca de 670 mil vagas líquidas no período. A diferença entre o saldo do CAGED e a variação da RAIS não é erro — as bases têm cobertura e prazos diferentes — e é justamente o que o nowcast da pergunta 5 modela.</a:t>
             </a:r>
             <a:endParaRPr lang="en-US" dirty="0"/>
           </a:p>
@@ -3412,7 +3412,7 @@
           <a:p>
             <a:r>
               <a:rPr lang="en-US" dirty="0"/>
-              <a:t>Na previsão, o SARIMA escolhido por validação de origem móvel erra 31% menos que repetir o mesmo mês do ano anterior. O Prophet, que estava na proposta, entrou na mesma validação: o melhor ficou em 16%, e com a tendência padrão ficou pior que o ingênuo — a série é completa e de sazonalidade estável, terreno do SARIMA. Mas o intervalo cruza o zero ao fim do primeiro ano, então projetar até 2030, como a proposta previa, seria um número sem conteúdo — reporto 18 meses com intervalo. O resultado forte é o nowcast: estimar o estoque do ano corrente, que a RAIS só publica um ano depois, a partir do fluxo do CAGED. Testei cada ano de 2014 a 2025 estimando só com os anos anteriores: o melhor estimador erra em média 2,1%, contra 5,1% do ingênuo, e em dez dos doze anos até 2,2%. Os anos ruins, 2018 e 2022, são saltos do estoque que o fluxo do CAGED não mostra. Estimar o presente rende mais do que prever o futuro.</a:t>
+              <a:t>Na previsão, o SARIMA escolhido por validação de origem móvel erra 33% menos que repetir o mesmo mês do ano anterior. O Prophet, que estava na proposta, entrou na mesma validação: o melhor ficou em 10,5%, e com a tendência padrão ficou pior que o ingênuo — a série é completa e de sazonalidade estável, terreno do SARIMA. Mas o intervalo cruza o zero ao fim do primeiro ano, então projetar até 2030, como a proposta previa, seria um número sem conteúdo — reporto 18 meses com intervalo. O resultado forte é o nowcast: estimar o estoque do ano corrente, que a RAIS só publica um ano depois, a partir do fluxo do CAGED. Testei cada ano de 2014 a 2025 estimando só com os anos anteriores: o melhor estimador erra em média 2,1%, contra 5,1% do ingênuo, e em dez dos doze anos até 2,2%. Os anos ruins, 2018 e 2022, são saltos do estoque que o fluxo do CAGED não mostra. Estimar o presente rende mais do que prever o futuro.</a:t>
             </a:r>
             <a:endParaRPr lang="en-US" dirty="0"/>
           </a:p>
@@ -4028,7 +4028,7 @@
           <a:p>
             <a:r>
               <a:rPr lang="en-US" dirty="0"/>
-              <a:t>O método foi o CRISP-DM, e o que importa nele aqui é o ciclo. A proposta definiu fontes, recorte e perguntas; a execução mostrou várias vezes que algo precisava mudar, e o trabalho voltava a uma fase anterior. Registrei doze desses retornos no TCC. Oito partiram da Avaliação: foi confrontando um resultado com o plausível que os defeitos apareceram. Quatro mudaram o que se perguntava — a projeção até 2030 virou nowcast do presente — e três trouxeram fontes que a proposta não previa. Vários resultados que vou mostrar existem por causa desses retornos.</a:t>
+              <a:t>O método foi o CRISP-DM, e o que importa nele aqui é o ciclo. A proposta definiu fontes, recorte e perguntas; a execução mostrou várias vezes que algo precisava mudar, e o trabalho voltava a uma fase anterior. Registrei os principais no TCC. A maioria partiu da Avaliação: foi confrontando um resultado com o plausível que os defeitos apareceram. Três mudaram o que se perguntava — a projeção até 2030 virou nowcast do presente. Vários resultados que vou mostrar existem por causa desses retornos.</a:t>
             </a:r>
             <a:endParaRPr lang="en-US" dirty="0"/>
           </a:p>
@@ -4116,7 +4116,7 @@
           <a:p>
             <a:r>
               <a:rPr lang="en-US" dirty="0"/>
-              <a:t>São 880 pacotes compactados no servidor FTP do Ministério, 53 gigabytes; descompactados, 661 gigabytes de texto. Convertidos para Parquet com compressão ZSTD, ficam em 56 gigabytes — onze vezes menos que o texto, e legíveis coluna a coluna. O recorte de tecnologia resultou em 23,8 milhões de registros da RAIS e 12,4 milhões de movimentações do CAGED. A redução é o que viabiliza tudo: a camada tratada tem 1,3 gigabyte. A RAIS dá o estoque, uma fotografia em 31 de dezembro; o CAGED dá o fluxo mensal.</a:t>
+              <a:t>São 880 pacotes compactados no servidor FTP do Ministério, 53 gigabytes; descompactados, 661 gigabytes de texto. Convertidos para Parquet com compressão ZSTD, ficam em 56 gigabytes — onze vezes menos que o texto, e legíveis coluna a coluna. O recorte de tecnologia resultou em 23,8 milhões de registros da RAIS e 12,2 milhões de movimentações do CAGED. A redução é o que viabiliza tudo: a camada tratada tem 1,3 gigabyte. A RAIS dá o estoque, uma fotografia em 31 de dezembro; o CAGED dá o fluxo mensal.</a:t>
             </a:r>
             <a:endParaRPr lang="en-US" dirty="0"/>
           </a:p>
@@ -5465,7 +5465,7 @@
                   <a:schemeClr val="tx1"/>
                 </a:solidFill>
               </a:rPr>
-              <a:t>697.163</a:t>
+              <a:t>670.691</a:t>
             </a:r>
             <a:endParaRPr lang="en-US" sz="3400" dirty="0"/>
           </a:p>
@@ -7377,7 +7377,7 @@
                   <a:schemeClr val="tx1"/>
                 </a:solidFill>
               </a:rPr>
-              <a:t>31% × 16%</a:t>
+              <a:t>33% × 10,5%</a:t>
             </a:r>
             <a:endParaRPr lang="en-US" sz="3600" dirty="0"/>
           </a:p>
@@ -11703,7 +11703,7 @@
                   <a:schemeClr val="tx1"/>
                 </a:solidFill>
               </a:rPr>
-              <a:t>12</a:t>
+              <a:t>9</a:t>
             </a:r>
             <a:endParaRPr lang="en-US" sz="3400" dirty="0"/>
           </a:p>
@@ -11717,7 +11717,7 @@
                   <a:schemeClr val="tx1"/>
                 </a:solidFill>
               </a:rPr>
-              <a:t>retornos</a:t>
+              <a:t>retornos principais</a:t>
             </a:r>
             <a:endParaRPr lang="en-US" sz="3400" dirty="0"/>
           </a:p>
@@ -12372,7 +12372,7 @@
                   <a:schemeClr val="tx1"/>
                 </a:solidFill>
               </a:rPr>
-              <a:t>12,4 mi</a:t>
+              <a:t>12,2 mi</a:t>
             </a:r>
             <a:endParaRPr lang="en-US" sz="3600" dirty="0"/>
           </a:p>
@@ -13862,7 +13862,7 @@
                   <a:schemeClr val="tx1"/>
                 </a:solidFill>
               </a:rPr>
-              <a:t>29 agregados</a:t>
+              <a:t>30 agregados</a:t>
             </a:r>
             <a:endParaRPr lang="en-US" sz="1300" dirty="0"/>
           </a:p>

</xml_diff>

<commit_message>
tcc: números da Gold sem o artefato de Rondônia; fases do crescimento, lentes no tempo, hiato ano a ano e conclusão reescrita
</commit_message>
<xml_diff>
--- a/apresentacao/apresentacao-tcc2.pptx
+++ b/apresentacao/apresentacao-tcc2.pptx
@@ -125,7 +125,7 @@
   <p:extLst>
     <p:ext uri="{521415D9-36F7-43E2-AB2F-B90AF26B5E84}">
       <p14:sectionLst xmlns:p14="http://schemas.microsoft.com/office/powerpoint/2010/main">
-        <p14:section name="Abertura" id="{31059a63-666f-8d3e-149a-fc26ea3d88a0}">
+        <p14:section name="Abertura" id="{6d4ec638-3123-08c1-8995-a4d7c82c11a7}">
           <p14:sldIdLst>
             <p14:sldId id="256"/>
             <p14:sldId id="257"/>
@@ -133,20 +133,20 @@
             <p14:sldId id="259"/>
           </p14:sldIdLst>
         </p14:section>
-        <p14:section name="Plataforma" id="{54b2530f-622a-d295-46de-7887caa87f6b}">
+        <p14:section name="Plataforma" id="{70b624a1-eccd-691e-ce6c-d612d3b66a3c}">
           <p14:sldIdLst>
             <p14:sldId id="260"/>
             <p14:sldId id="261"/>
             <p14:sldId id="262"/>
           </p14:sldIdLst>
         </p14:section>
-        <p14:section name="Qualidade do dado" id="{c38c57ec-312b-0eaa-7298-17e7708b981d}">
+        <p14:section name="Qualidade do dado" id="{3505d416-d8c4-6260-a79a-d8b6427572bb}">
           <p14:sldIdLst>
             <p14:sldId id="263"/>
             <p14:sldId id="264"/>
           </p14:sldIdLst>
         </p14:section>
-        <p14:section name="Resultados" id="{a3558d33-5037-0d5e-5fab-4fbbf604be93}">
+        <p14:section name="Resultados" id="{10c1149e-c6a4-138b-e45f-f825282614c9}">
           <p14:sldIdLst>
             <p14:sldId id="265"/>
             <p14:sldId id="266"/>
@@ -156,7 +156,7 @@
             <p14:sldId id="270"/>
           </p14:sldIdLst>
         </p14:section>
-        <p14:section name="Entrega" id="{5ff93034-e9fd-0050-8f40-773969475360}">
+        <p14:section name="Entrega" id="{fbe0c78c-b7ad-5fa2-b163-5b89115e961a}">
           <p14:sldIdLst>
             <p14:sldId id="271"/>
             <p14:sldId id="272"/>
@@ -622,16 +622,16 @@
                 <c:formatCode>General</c:formatCode>
                 <c:ptCount val="19"/>
                 <c:pt idx="0">
-                  <c:v>560.04</c:v>
+                  <c:v>519.271</c:v>
                 </c:pt>
                 <c:pt idx="1">
-                  <c:v>615.662</c:v>
+                  <c:v>571.889</c:v>
                 </c:pt>
                 <c:pt idx="2">
-                  <c:v>655.413</c:v>
+                  <c:v>610.24</c:v>
                 </c:pt>
                 <c:pt idx="3">
-                  <c:v>714.598</c:v>
+                  <c:v>665.611</c:v>
                 </c:pt>
                 <c:pt idx="4">
                   <c:v>708.607</c:v>
@@ -655,19 +655,19 @@
                   <c:v>782.309</c:v>
                 </c:pt>
                 <c:pt idx="11">
-                  <c:v>866.624</c:v>
+                  <c:v>822.495</c:v>
                 </c:pt>
                 <c:pt idx="12">
-                  <c:v>895.83</c:v>
+                  <c:v>854.478</c:v>
                 </c:pt>
                 <c:pt idx="13">
-                  <c:v>943.105</c:v>
+                  <c:v>899.84</c:v>
                 </c:pt>
                 <c:pt idx="14">
                   <c:v>1073.706</c:v>
                 </c:pt>
                 <c:pt idx="15">
-                  <c:v>1258.939</c:v>
+                  <c:v>1219.223</c:v>
                 </c:pt>
                 <c:pt idx="16">
                   <c:v>1261.089</c:v>
@@ -1274,16 +1274,16 @@
                 <c:formatCode>General</c:formatCode>
                 <c:ptCount val="19"/>
                 <c:pt idx="0">
-                  <c:v>3.24</c:v>
+                  <c:v>3.39</c:v>
                 </c:pt>
                 <c:pt idx="1">
-                  <c:v>3.2</c:v>
+                  <c:v>3.33</c:v>
                 </c:pt>
                 <c:pt idx="2">
-                  <c:v>3.11</c:v>
+                  <c:v>3.21</c:v>
                 </c:pt>
                 <c:pt idx="3">
-                  <c:v>3.05</c:v>
+                  <c:v>3.07</c:v>
                 </c:pt>
                 <c:pt idx="4">
                   <c:v>3.3</c:v>
@@ -1307,19 +1307,19 @@
                   <c:v>3.42</c:v>
                 </c:pt>
                 <c:pt idx="11">
-                  <c:v>3.38</c:v>
+                  <c:v>3.46</c:v>
                 </c:pt>
                 <c:pt idx="12">
-                  <c:v>3.3</c:v>
+                  <c:v>3.44</c:v>
                 </c:pt>
                 <c:pt idx="13">
-                  <c:v>3.29</c:v>
+                  <c:v>3.3</c:v>
                 </c:pt>
                 <c:pt idx="14">
                   <c:v>3.37</c:v>
                 </c:pt>
                 <c:pt idx="15">
-                  <c:v>3.59</c:v>
+                  <c:v>3.56</c:v>
                 </c:pt>
                 <c:pt idx="16">
                   <c:v>3.49</c:v>
@@ -2309,13 +2309,13 @@
                 <c:ptCount val="4"/>
                 <c:lvl>
                   <c:pt idx="0">
-                    <c:v>Identidade</c:v>
+                    <c:v>Razão mediana</c:v>
                   </c:pt>
                   <c:pt idx="1">
-                    <c:v>Razão mediana</c:v>
+                    <c:v>Regressão OLS</c:v>
                   </c:pt>
                   <c:pt idx="2">
-                    <c:v>Regressão OLS</c:v>
+                    <c:v>Identidade</c:v>
                   </c:pt>
                   <c:pt idx="3">
                     <c:v>Ingênuo</c:v>
@@ -2331,16 +2331,16 @@
                 <c:formatCode>General</c:formatCode>
                 <c:ptCount val="4"/>
                 <c:pt idx="0">
-                  <c:v>2.12</c:v>
+                  <c:v>1.14</c:v>
                 </c:pt>
                 <c:pt idx="1">
-                  <c:v>2.18</c:v>
+                  <c:v>1.44</c:v>
                 </c:pt>
                 <c:pt idx="2">
-                  <c:v>2.49</c:v>
+                  <c:v>1.6</c:v>
                 </c:pt>
                 <c:pt idx="3">
-                  <c:v>5.09</c:v>
+                  <c:v>5.1</c:v>
                 </c:pt>
               </c:numCache>
             </c:numRef>
@@ -2972,7 +2972,7 @@
           <a:p>
             <a:r>
               <a:rPr lang="en-US" dirty="0"/>
-              <a:t>Primeira resposta: o estoque passou de 560 mil vínculos em 2007 para 1,36 milhão em 2025, crescimento de 143%. O crescimento não é uniforme: o salto está em 2021 e 2022, a aceleração digital da pandemia, e depois desacelera. O CAGED confirma, com cerca de 670 mil vagas líquidas no período. A diferença entre o saldo do CAGED e a variação da RAIS não é erro — as bases têm cobertura e prazos diferentes — e é justamente o que o nowcast da pergunta 5 modela.</a:t>
+              <a:t>Primeira resposta: o estoque passou de 519 mil vínculos em 2007 para 1,36 milhão em 2025, crescimento de 162%, ou 5,5% ao ano. A média esconde ondas: queda na recessão de 2014 a 2017, e 38% de todo o crescimento concentrado em 2021 e 2022, a aceleração digital da pandemia. Depois, o ritmo caiu para 3,7% ao ano. O CAGED confirma, com cerca de 670 mil vagas líquidas no período. A diferença entre o saldo do CAGED e a variação da RAIS não é erro — as bases têm cobertura e prazos diferentes — e é justamente o que o nowcast da pergunta 5 modela.</a:t>
             </a:r>
             <a:endParaRPr lang="en-US" dirty="0"/>
           </a:p>
@@ -3060,7 +3060,7 @@
           <a:p>
             <a:r>
               <a:rPr lang="en-US" dirty="0"/>
-              <a:t>Este é o achado central. 58% dos profissionais de TI estão fora das empresas de TI. E ganham praticamente o mesmo: 4,13 salários mínimos de mediana, contra 4,31 de quem está dentro, com mais tempo de emprego. Em 2007 o prêmio de estar numa empresa de TI era grande, e encolheu. E o terceiro grupo — quem trabalha em empresa de TI em outra função — ganha menos da metade. Um recorte só pelo CNAE mistura esse grupo com os profissionais e não vê a maioria deles.</a:t>
+              <a:t>Este é o achado central. 58% dos profissionais de TI estão fora das empresas de TI, e ganham praticamente o mesmo: 4,13 salários mínimos de mediana, contra 4,31 de quem está dentro. Mas a direção é a oposta da que se imagina: em 2007 eram 71% fora. O crescimento se concentrou dentro das empresas de TI, que quadruplicaram seus profissionais, o que é coerente com a terceirização dos serviços de tecnologia. E a mediana caiu cerca de um quinto nos dois grupos. E o terceiro grupo — quem trabalha em empresa de TI em outra função — ganha menos da metade. Um recorte só pelo CNAE mistura esse grupo com os profissionais e não vê a maioria deles.</a:t>
             </a:r>
             <a:endParaRPr lang="en-US" dirty="0"/>
           </a:p>
@@ -3148,7 +3148,7 @@
           <a:p>
             <a:r>
               <a:rPr lang="en-US" dirty="0"/>
-              <a:t>No território, São Paulo tem 41% do estoque. Por isso fiz uma análise de sensibilidade: SP cresceu 154% e o resto do país 136% — a conclusão de crescimento não depende de SP. Mas a remuneração sim: a mediana paulista subiu e a do resto caiu, e a estabilidade nacional é a soma desses dois movimentos. O agrupamento de municípios mostra ainda que, entre 2020 e 2025, o interior cresceu 54% e as capitais 38%. Uma ressalva importante: a localização é a do estabelecimento, não a do trabalho.</a:t>
+              <a:t>No território, São Paulo tem 41% do estoque. Por isso fiz uma análise de sensibilidade: SP cresceu 154% e o resto do país 168% — a conclusão de crescimento não depende de SP. Mas a remuneração sim: a mediana paulista subiu e a do resto caiu, e a estabilidade nacional é a soma desses dois movimentos. O agrupamento de municípios mostra ainda que, entre 2020 e 2025, o interior cresceu 54% e as capitais 49%. Uma ressalva importante: a localização é a do estabelecimento, não a de quem trabalha. Quem mora em Londrina e trabalha remoto para uma empresa de São Paulo conta como São Paulo.</a:t>
             </a:r>
             <a:endParaRPr lang="en-US" dirty="0"/>
           </a:p>
@@ -3236,7 +3236,7 @@
           <a:p>
             <a:r>
               <a:rPr lang="en-US" dirty="0"/>
-              <a:t>Crescer não é melhorar. A remuneração mediana, medida em salários mínimos para comparar 2007 com 2025 sem escolher deflator, foi de 3,24 para 3,41: 5% em dezoito anos. O emprego dobrou, a posição relativa do salário ficou onde estava. À direita, o risco de desligamento por tempo de casa: o pico não é nos primeiros meses, é entre 6 e 12, e cai depois. Aqui também há um erro registrado: a primeira tentativa usou Kaplan-Meier e deu 48 anos de permanência — o estimador supõe coorte, e a RAIS é corte transversal. A tábua de vida de período responde à pergunta certa.</a:t>
+              <a:t>Crescer não é melhorar. A remuneração mediana, medida em salários mínimos para comparar 2007 com 2025 sem escolher deflator, foi de 3,39 para 3,41: estável. O salário acompanhou o mínimo, que teve ganho real, mas não se afastou dele. E para os profissionais de TI, dentro e fora das empresas de TI, a mediana caiu cerca de um quinto. À direita, o risco de desligamento por tempo de casa: o pico não é nos primeiros meses, é entre 6 e 12, e cai depois. Aqui também há um erro registrado: a primeira tentativa usou Kaplan-Meier e deu 48 anos de permanência — o estimador supõe coorte, e a RAIS é corte transversal. A tábua de vida de período responde à pergunta certa.</a:t>
             </a:r>
             <a:endParaRPr lang="en-US" dirty="0"/>
           </a:p>
@@ -3324,7 +3324,7 @@
           <a:p>
             <a:r>
               <a:rPr lang="en-US" dirty="0"/>
-              <a:t>A decomposição de Oaxaca-Blinder separa o hiato em uma parte explicada pelas características observadas — escolaridade, área, porte, região, idade, jornada — e uma não explicada. No gênero, a parte explicada é negativa: pelas características, as mulheres deveriam ganhar mais. Toda a diferença é de retorno. Na raça é o oposto: a maior parte é explicada, ou seja, acesso às posições que pagam mais. Uma cautela: a parcela não explicada não mede discriminação, é um limite superior. E a participação feminina caiu de 34% para 31%.</a:t>
+              <a:t>A decomposição de Oaxaca-Blinder separa o hiato em uma parte explicada pelas características observadas — escolaridade, área, porte, região, idade, jornada — e uma não explicada. No gênero, a parte explicada é negativa: pelas características, as mulheres deveriam ganhar mais. Toda a diferença é de retorno. Na raça é o oposto: a maior parte é explicada, ou seja, acesso às posições que pagam mais. No tempo, os dois eixos andam em sentidos opostos. O hiato racial caiu de 64% para 38%, quase todo pela parcela explicada: pessoas negras passaram a chegar mais às posições que pagam melhor. O de gênero era zero ou negativo até 2015 e chegou a 7,8%: a penalidade de retorno sempre existiu, e o que encolheu foi a vantagem de características das mulheres. Uma cautela: a parcela não explicada não mede discriminação, é um limite superior. E a participação feminina caiu de 32,5% para 30,6%.</a:t>
             </a:r>
             <a:endParaRPr lang="en-US" dirty="0"/>
           </a:p>
@@ -3412,7 +3412,7 @@
           <a:p>
             <a:r>
               <a:rPr lang="en-US" dirty="0"/>
-              <a:t>Na previsão, o SARIMA escolhido por validação de origem móvel erra 33% menos que repetir o mesmo mês do ano anterior. O Prophet, que estava na proposta, entrou na mesma validação: o melhor ficou em 10,5%, e com a tendência padrão ficou pior que o ingênuo — a série é completa e de sazonalidade estável, terreno do SARIMA. Mas o intervalo cruza o zero ao fim do primeiro ano, então projetar até 2030, como a proposta previa, seria um número sem conteúdo — reporto 18 meses com intervalo. O resultado forte é o nowcast: estimar o estoque do ano corrente, que a RAIS só publica um ano depois, a partir do fluxo do CAGED. Testei cada ano de 2014 a 2025 estimando só com os anos anteriores: o melhor estimador erra em média 2,1%, contra 5,1% do ingênuo, e em dez dos doze anos até 2,2%. Os anos ruins, 2018 e 2022, são saltos do estoque que o fluxo do CAGED não mostra. Estimar o presente rende mais do que prever o futuro.</a:t>
+              <a:t>Na previsão, o SARIMA escolhido por validação de origem móvel erra 33% menos que repetir o mesmo mês do ano anterior. O Prophet, que estava na proposta, entrou na mesma validação: o melhor ficou em 10,5%, e com a tendência padrão ficou pior que o ingênuo — a série é completa e de sazonalidade estável, terreno do SARIMA. Mas o intervalo cruza o zero ao fim do primeiro ano, então projetar até 2030, como a proposta previa, seria um número sem conteúdo — reporto 18 meses com intervalo. O resultado forte é o nowcast: estimar o estoque do ano corrente, que a RAIS só publica um ano depois, a partir do fluxo do CAGED. Testei cada ano de 2014 a 2025 estimando só com os anos anteriores: o melhor estimador, a razão mediana, erra em média 1,1%, contra 5,1% do ingênuo. Antes da correção de Rondônia, o erro era 2,1% e os piores anos eram 2018 e 2022 — justamente anos em que o funcionalismo do estado entrou no estoque sem passar pelo CAGED. Para 2026, o nowcast projeta 1,37 milhão de vínculos, alta de 0,7%. Estimar o presente rende mais do que prever o futuro.</a:t>
             </a:r>
             <a:endParaRPr lang="en-US" dirty="0"/>
           </a:p>
@@ -3588,7 +3588,7 @@
           <a:p>
             <a:r>
               <a:rPr lang="en-US" dirty="0"/>
-              <a:t>Juntando as cinco respostas: o mercado cresceu muito, deixou de ser um setor para virar uma função distribuída pela economia, e esse crescimento não se converteu em melhora de remuneração relativa nem em redução das desigualdades de gênero e raça.</a:t>
+              <a:t>Juntando as cinco respostas, e respondendo à pergunta central: o crescimento não veio com salários relativos melhores e trouxe mais equidade em um eixo e menos no outro. O mercado cresceu muito, mas em ondas, e cresceu sobretudo dentro das empresas de TI. O hiato racial caiu, por acesso; o de gênero surgiu, e as mulheres perderam participação.</a:t>
             </a:r>
             <a:endParaRPr lang="en-US" dirty="0"/>
           </a:p>
@@ -3676,7 +3676,7 @@
           <a:p>
             <a:r>
               <a:rPr lang="en-US" dirty="0"/>
-              <a:t>As limitações estão declaradas. A RAIS e o CAGED só veem o mercado formal, e em TI a contratação como PJ é comum. A localização é a do estabelecimento. A decomposição não mede discriminação. A validação externa cobre só a lente de ocupação — estendê-la à lente de setor com o cadastro de empresas do IBGE fica como trabalho futuro —, e o nowcast erra mais nos anos de salto do estoque. Como próximos passos: medir retenção por gênero cruzando as duas bases, a decomposição regional, e reaproveitar o pipeline para outros recortes — basta trocar a lista de códigos.</a:t>
+              <a:t>As limitações estão declaradas. A RAIS e o CAGED só veem o mercado formal: em TI a contratação como PJ é comum, e muitos brasileiros trabalham para empresas do exterior. A localização é a do estabelecimento, e com o trabalho remoto ela pode estar longe de onde a pessoa vive. A decomposição não mede discriminação. A validação externa cobre só a lente de ocupação — estendê-la à lente de setor com o cadastro de empresas do IBGE fica como trabalho futuro —, e o nowcast erra mais nos anos de salto do estoque. Como próximos passos: explicar o hiato de gênero que surgiu, separando entrada e permanência; testar a hipótese da terceirização com as contas nacionais; medir o mercado além do emprego formal, o que pede uma análise quase global; e reaproveitar o pipeline para outros recortes — basta trocar a lista de códigos.</a:t>
             </a:r>
             <a:endParaRPr lang="en-US" dirty="0"/>
           </a:p>
@@ -4468,7 +4468,7 @@
           <a:p>
             <a:r>
               <a:rPr lang="en-US" dirty="0"/>
-              <a:t>A auditoria encontrou defeitos na fonte e um erro meu. O mais instrutivo é a ingestão parcial: a verificação perguntava se cada arquivo tinha saída, e tinha — mas faltavam pedaços. Só apareceu porque a série ficou implausível, 2022 abaixo de 2021. A correção foi reconstruir e passar a verificar pedaço a pedaço. E registro o meu erro de método: calculei a mediana do total como média das medianas dos grupos. Mediana não se soma. Corrigido, a comparação entre as lentes se inverteu. Todos os números da apresentação são da versão corrigida.</a:t>
+              <a:t>A auditoria encontrou defeitos na fonte e um erro meu. O de maior efeito é o de Rondônia: o governo do estado declara o funcionalismo inteiro sob um código só, que alterna entre programador e operador de máquinas. Nos anos de programador, são uns 45 mil falsos profissionais de TI, o maior grupo do país. Excluído na Gold, o crescimento passou de 143% para 162% e o hiato de gênero de 2007 deixou de ser 19% para ser quase zero. O mais instrutivo sobre o processo é a ingestão parcial: a verificação perguntava se cada arquivo tinha saída, e tinha — mas faltavam pedaços. Só apareceu porque a série ficou implausível, 2022 abaixo de 2021. A correção foi reconstruir e passar a verificar pedaço a pedaço. E registro o meu erro de método: calculei a mediana do total como média das medianas dos grupos. Mediana não se soma. Corrigido, a comparação entre as lentes se inverteu. Todos os números da apresentação são da versão corrigida.</a:t>
             </a:r>
             <a:endParaRPr lang="en-US" dirty="0"/>
           </a:p>
@@ -5341,7 +5341,7 @@
                   <a:schemeClr val="tx1"/>
                 </a:solidFill>
               </a:rPr>
-              <a:t>O estoque mais que dobrou, com o salto em 2021–2022</a:t>
+              <a:t>5,5% ao ano, mas em ondas: o salto foi em 2021–2022</a:t>
             </a:r>
             <a:endParaRPr lang="en-US" sz="2800" dirty="0"/>
           </a:p>
@@ -5393,7 +5393,7 @@
                   <a:schemeClr val="tx1"/>
                 </a:solidFill>
               </a:rPr>
-              <a:t>+143%</a:t>
+              <a:t>+162%</a:t>
             </a:r>
             <a:endParaRPr lang="en-US" sz="4800" dirty="0"/>
           </a:p>
@@ -5429,7 +5429,7 @@
                   <a:schemeClr val="tx2"/>
                 </a:solidFill>
               </a:rPr>
-              <a:t>de 560.040 (2007) para 1.361.231 (2025)</a:t>
+              <a:t>de 519.271 (2007) para 1.361.231 (2025)</a:t>
             </a:r>
             <a:endParaRPr lang="en-US" sz="1400" dirty="0"/>
           </a:p>
@@ -5540,7 +5540,7 @@
                   <a:schemeClr val="tx2"/>
                 </a:solidFill>
               </a:rPr>
-              <a:t>Depois de 2022, o ritmo desacelera.</a:t>
+              <a:t>38% do ganho veio de 2020–2022; depois, 3,7% ao ano.</a:t>
             </a:r>
             <a:endParaRPr lang="en-US" sz="1500" dirty="0"/>
           </a:p>
@@ -5720,7 +5720,7 @@
                   <a:schemeClr val="tx1"/>
                 </a:solidFill>
               </a:rPr>
-              <a:t>TI deixou de ser um setor para virar uma função</a:t>
+              <a:t>A maioria está fora, mas o crescimento foi dentro</a:t>
             </a:r>
             <a:endParaRPr lang="en-US" sz="2800" dirty="0"/>
           </a:p>
@@ -5847,7 +5847,7 @@
                   <a:schemeClr val="tx1"/>
                 </a:solidFill>
               </a:rPr>
-              <a:t>Fora do setor, o salário é próximo e a permanência é maior: </a:t>
+              <a:t>Em 2007, eram 71% fora: </a:t>
             </a:r>
             <a:pPr indent="0" marL="0">
               <a:spcAft>
@@ -5861,7 +5861,7 @@
                   <a:schemeClr val="tx1"/>
                 </a:solidFill>
               </a:rPr>
-              <a:t>59 meses de emprego, contra 43. Em 2007, quem estava dentro ganhava bem mais (5,47 contra 4,22 SM); o prêmio do setor encolheu.</a:t>
+              <a:t>dentro das empresas de TI, os profissionais foram multiplicados por 4,2; fora, por 2,4. A mediana caiu nos dois grupos: 5,47 → 4,31 dentro e 5,02 → 4,13 fora.</a:t>
             </a:r>
             <a:endParaRPr lang="en-US" sz="1500" dirty="0"/>
           </a:p>
@@ -6041,7 +6041,7 @@
                   <a:schemeClr val="tx1"/>
                 </a:solidFill>
               </a:rPr>
-              <a:t>São Paulo concentra; o interior cresce mais rápido</a:t>
+              <a:t>São Paulo concentra; o interior cresce um pouco mais</a:t>
             </a:r>
             <a:endParaRPr lang="en-US" sz="2800" dirty="0"/>
           </a:p>
@@ -6203,7 +6203,7 @@
                   <a:schemeClr val="tx1"/>
                 </a:solidFill>
               </a:rPr>
-              <a:t>+154% × +136%</a:t>
+              <a:t>+154% × +168%</a:t>
             </a:r>
             <a:endParaRPr lang="en-US" sz="3400" dirty="0"/>
           </a:p>
@@ -6338,7 +6338,7 @@
                   <a:schemeClr val="tx2"/>
                 </a:solidFill>
               </a:rPr>
-              <a:t>mediana em 2025: SP subiu desde 2007 (4,20), o resto do país caiu (2,81)</a:t>
+              <a:t>mediana em 2025: SP subiu desde 2007 (4,20), o resto do país caiu (2,89)</a:t>
             </a:r>
             <a:endParaRPr lang="en-US" sz="1400" dirty="0"/>
           </a:p>
@@ -6401,7 +6401,7 @@
                   <a:schemeClr val="tx1"/>
                 </a:solidFill>
               </a:rPr>
-              <a:t>+54% × +38%</a:t>
+              <a:t>+54% × +49%</a:t>
             </a:r>
             <a:endParaRPr lang="en-US" sz="3400" dirty="0"/>
           </a:p>
@@ -6688,7 +6688,7 @@
                   <a:schemeClr val="tx1"/>
                 </a:solidFill>
               </a:rPr>
-              <a:t>3,24 → 3,41 SM: </a:t>
+              <a:t>3,39 → 3,41 SM: </a:t>
             </a:r>
             <a:pPr indent="0" marL="0">
               <a:spcAft>
@@ -6702,7 +6702,7 @@
                   <a:schemeClr val="tx1"/>
                 </a:solidFill>
               </a:rPr>
-              <a:t>alta de 5% em dezoito anos, enquanto o emprego mais que dobrou.</a:t>
+              <a:t>estável, enquanto o emprego mais que dobrou; a dos profissionais de TI caiu um quinto.</a:t>
             </a:r>
             <a:endParaRPr lang="en-US" sz="1500" dirty="0"/>
           </a:p>
@@ -6935,7 +6935,7 @@
                   <a:schemeClr val="tx1"/>
                 </a:solidFill>
               </a:rPr>
-              <a:t>Gênero é diferença de retorno; raça, de acesso</a:t>
+              <a:t>O hiato racial caiu; o de gênero surgiu</a:t>
             </a:r>
             <a:endParaRPr lang="en-US" sz="2800" dirty="0"/>
           </a:p>
@@ -6987,7 +6987,7 @@
                   <a:schemeClr val="tx1"/>
                 </a:solidFill>
               </a:rPr>
-              <a:t>19,0% → 7,8%</a:t>
+              <a:t>64% → 38%</a:t>
             </a:r>
             <a:endParaRPr lang="en-US" sz="3400" dirty="0"/>
           </a:p>
@@ -7023,7 +7023,7 @@
                   <a:schemeClr val="tx2"/>
                 </a:solidFill>
               </a:rPr>
-              <a:t>hiato bruto de gênero, 2007 a 2025 — e a parcela explicada é negativa</a:t>
+              <a:t>hiato bruto branca × parda, 2007 a 2025: caiu por melhora de acesso</a:t>
             </a:r>
             <a:endParaRPr lang="en-US" sz="1400" dirty="0"/>
           </a:p>
@@ -7059,7 +7059,7 @@
                   <a:schemeClr val="tx1"/>
                 </a:solidFill>
               </a:rPr>
-              <a:t>34,3% → 30,6%</a:t>
+              <a:t>−0,9% → 7,8%</a:t>
             </a:r>
             <a:endParaRPr lang="en-US" sz="3400" dirty="0"/>
           </a:p>
@@ -7095,7 +7095,7 @@
                   <a:schemeClr val="tx2"/>
                 </a:solidFill>
               </a:rPr>
-              <a:t>participação feminina no estoque: o setor cresceu e ficou menos feminino</a:t>
+              <a:t>hiato bruto de gênero: surgiu depois de 2015, todo de retorno</a:t>
             </a:r>
             <a:endParaRPr lang="en-US" sz="1400" dirty="0"/>
           </a:p>
@@ -7134,7 +7134,7 @@
                   <a:schemeClr val="tx2"/>
                 </a:solidFill>
               </a:rPr>
-              <a:t>Equidade salarial na empresa atua sobre o hiato de gênero; política de acesso, sobre o racial.</a:t>
+              <a:t>Participação feminina: 32,5% → 30,6%. Equidade salarial atua sobre o hiato de gênero; política de acesso, sobre o racial.</a:t>
             </a:r>
             <a:endParaRPr lang="en-US" sz="1400" dirty="0"/>
           </a:p>
@@ -7507,7 +7507,7 @@
                   <a:schemeClr val="tx1"/>
                 </a:solidFill>
               </a:rPr>
-              <a:t>Cada ano estimado só com os anteriores. Em 10 dos 12 anos, erro de até 2,2%; os piores são 2018 e 2022, saltos que o fluxo não antecipa.</a:t>
+              <a:t>Cada ano estimado só com os anteriores; em 10 dos 12, erro abaixo de 2,3%. Para 2026: 1,37 milhão de vínculos, alta de 0,7%.</a:t>
             </a:r>
             <a:endParaRPr lang="en-US" sz="1500" dirty="0"/>
           </a:p>
@@ -8308,7 +8308,7 @@
                   <a:schemeClr val="tx1"/>
                 </a:solidFill>
               </a:rPr>
-              <a:t>Cresceu muito, mudou de lugar, não ficou mais justo</a:t>
+              <a:t>Cresceu em ondas, dentro do setor, sem pagar mais</a:t>
             </a:r>
             <a:endParaRPr lang="en-US" sz="2800" dirty="0"/>
           </a:p>
@@ -8405,7 +8405,7 @@
                   <a:schemeClr val="tx1"/>
                 </a:solidFill>
               </a:rPr>
-              <a:t>+143% em dezoito anos, salto em 2021–2022</a:t>
+              <a:t>+162% (5,5% ao ano), em ondas</a:t>
             </a:r>
             <a:endParaRPr lang="en-US" sz="1600" dirty="0"/>
           </a:p>
@@ -8502,7 +8502,7 @@
                   <a:schemeClr val="tx1"/>
                 </a:solidFill>
               </a:rPr>
-              <a:t>58% dos profissionais fora de empresas de TI</a:t>
+              <a:t>58% fora, mas o crescimento foi dentro das empresas de TI</a:t>
             </a:r>
             <a:endParaRPr lang="en-US" sz="1600" dirty="0"/>
           </a:p>
@@ -8599,7 +8599,7 @@
                   <a:schemeClr val="tx1"/>
                 </a:solidFill>
               </a:rPr>
-              <a:t>Mediana em SM praticamente parada: 3,24 → 3,41</a:t>
+              <a:t>Mediana em SM estável: 3,39 → 3,41</a:t>
             </a:r>
             <a:endParaRPr lang="en-US" sz="1600" dirty="0"/>
           </a:p>
@@ -8696,7 +8696,7 @@
                   <a:schemeClr val="tx1"/>
                 </a:solidFill>
               </a:rPr>
-              <a:t>Gênero: retorno. Raça: acesso. Menos mulheres</a:t>
+              <a:t>Hiato racial caiu; o de gênero surgiu</a:t>
             </a:r>
             <a:endParaRPr lang="en-US" sz="1600" dirty="0"/>
           </a:p>
@@ -8793,7 +8793,7 @@
                   <a:schemeClr val="tx1"/>
                 </a:solidFill>
               </a:rPr>
-              <a:t>Futuro incerto; presente estimado com erro médio de 2,1%</a:t>
+              <a:t>Presente estimado com erro médio de 1,1%</a:t>
             </a:r>
             <a:endParaRPr lang="en-US" sz="1600" dirty="0"/>
           </a:p>
@@ -8876,7 +8876,7 @@
                   <a:schemeClr val="bg1"/>
                 </a:solidFill>
               </a:rPr>
-              <a:t>O emprego formal de tecnologia deixou de ser um setor para virar uma função distribuída pela economia — e esse crescimento não se converteu em remuneração relativa maior nem em menos desigualdade.</a:t>
+              <a:t>O emprego formal de tecnologia cresceu muito, em ondas e sobretudo dentro das empresas de TI. Não elevou a remuneração frente ao salário mínimo, reduziu o hiato racial e fez surgir um hiato de gênero.</a:t>
             </a:r>
             <a:endParaRPr lang="en-US" sz="1600" dirty="0"/>
           </a:p>
@@ -9123,7 +9123,7 @@
                   <a:schemeClr val="tx1"/>
                 </a:solidFill>
               </a:rPr>
-              <a:t>Só o mercado formal: contratação como PJ fica de fora</a:t>
+              <a:t>Só o mercado formal: PJ e quem trabalha para o exterior ficam de fora</a:t>
             </a:r>
             <a:endParaRPr lang="en-US" sz="1500" dirty="0"/>
           </a:p>
@@ -9141,7 +9141,7 @@
                   <a:schemeClr val="tx1"/>
                 </a:solidFill>
               </a:rPr>
-              <a:t>Local do estabelecimento, não do trabalho</a:t>
+              <a:t>Local do empregador, não de quem trabalha remoto</a:t>
             </a:r>
             <a:endParaRPr lang="en-US" sz="1500" dirty="0"/>
           </a:p>
@@ -9280,7 +9280,7 @@
                   <a:schemeClr val="bg1"/>
                 </a:solidFill>
               </a:rPr>
-              <a:t>Retenção por gênero cruzando CAGED (entrada) e RAIS (permanência)</a:t>
+              <a:t>Explicar o hiato de gênero: entrada (CAGED) × permanência (RAIS)</a:t>
             </a:r>
             <a:endParaRPr lang="en-US" sz="1500" dirty="0"/>
           </a:p>
@@ -9298,7 +9298,7 @@
                   <a:schemeClr val="bg1"/>
                 </a:solidFill>
               </a:rPr>
-              <a:t>Decomposição shift-share do crescimento regional</a:t>
+              <a:t>Testar a terceirização com as contas nacionais do IBGE</a:t>
             </a:r>
             <a:endParaRPr lang="en-US" sz="1500" dirty="0"/>
           </a:p>
@@ -9316,7 +9316,7 @@
                   <a:schemeClr val="bg1"/>
                 </a:solidFill>
               </a:rPr>
-              <a:t>Linhagem navegável da Gold com transformação declarativa</a:t>
+              <a:t>Mercado além do formal: PJ, MEI e trabalho para o exterior</a:t>
             </a:r>
             <a:endParaRPr lang="en-US" sz="1500" dirty="0"/>
           </a:p>
@@ -11703,7 +11703,7 @@
                   <a:schemeClr val="tx1"/>
                 </a:solidFill>
               </a:rPr>
-              <a:t>9</a:t>
+              <a:t>10</a:t>
             </a:r>
             <a:endParaRPr lang="en-US" sz="3400" dirty="0"/>
           </a:p>
@@ -15089,7 +15089,7 @@
                   <a:schemeClr val="tx1"/>
                 </a:solidFill>
               </a:rPr>
-              <a:t>Código sem dicionário</a:t>
+              <a:t>Servidores de Rondônia</a:t>
             </a:r>
             <a:endParaRPr lang="en-US" sz="1900" dirty="0"/>
           </a:p>
@@ -15161,7 +15161,7 @@
                   <a:schemeClr val="tx1"/>
                 </a:solidFill>
               </a:rPr>
-              <a:t>O CBO 211220 tem milhares de vínculos no microdado e não está em nenhum dicionário oficial do MTE.</a:t>
+              <a:t>O governo de Rondônia declara seus ~45 mil servidores como programadores em 8 anos: 7% do estoque de 2007, e invertia o hiato de gênero.</a:t>
             </a:r>
             <a:endParaRPr lang="en-US" sz="1500" dirty="0"/>
           </a:p>

</xml_diff>